<commit_message>
Stage 8 review fixes: HO-003
</commit_message>
<xml_diff>
--- a/output/archive/Tarnovell_Group/People/Organisation/2025/Group_Organisation_Chart_2025-11.pptx
+++ b/output/archive/Tarnovell_Group/People/Organisation/2025/Group_Organisation_Chart_2025-11.pptx
@@ -4192,7 +4192,7 @@
               <a:rPr sz="2000">
                 <a:latin typeface="Arial"/>
               </a:rPr>
-              <a:t>Shared administration now sits in one group function: finance, HR and payroll, IT and the common SharePoint estate</a:t>
+              <a:t>Shared administration is coordinated by the relevant group function owners; IT and SharePoint migration remain in progress, with local shares preserved as archive roots</a:t>
             </a:r>
           </a:p>
           <a:p>
@@ -4347,7 +4347,7 @@
                 </a:solidFill>
                 <a:latin typeface="Arial"/>
               </a:rPr>
-              <a:t>Changes since the last issue</a:t>
+              <a:t>Directory and ownership controls</a:t>
             </a:r>
           </a:p>
         </p:txBody>
@@ -4379,7 +4379,7 @@
               <a:rPr sz="2000">
                 <a:latin typeface="Arial"/>
               </a:rPr>
-              <a:t>Two head office roles were confirmed in September and appear for the first time on this chart</a:t>
+              <a:t>A-F directory entries are consolidated; retained scientific roles remain within each site</a:t>
             </a:r>
           </a:p>
           <a:p>
@@ -4388,7 +4388,7 @@
               <a:rPr sz="2000">
                 <a:latin typeface="Arial"/>
               </a:rPr>
-              <a:t>Firm F reporting lines moved to the group function owners on completion of the HR directory consolidation</a:t>
+              <a:t>Directory consolidation does not itself establish completion of archive or systems migration</a:t>
             </a:r>
           </a:p>
           <a:p>
@@ -4397,7 +4397,7 @@
               <a:rPr sz="2000">
                 <a:latin typeface="Arial"/>
               </a:rPr>
-              <a:t>Leaver folders and their ownership are being checked before any reporting line is changed in the directory</a:t>
+              <a:t>Leaver folders require ownership checks before migration acceptance</a:t>
             </a:r>
           </a:p>
           <a:p>
@@ -4406,7 +4406,7 @@
               <a:rPr sz="2000">
                 <a:latin typeface="Arial"/>
               </a:rPr>
-              <a:t>Please raise any error on your firm's branch with People Operations by the end of November</a:t>
+              <a:t>Please raise any error on your firm branch with People Operations by the end of November</a:t>
             </a:r>
           </a:p>
         </p:txBody>

</xml_diff>